<commit_message>
Add Hebrew presenter (speaker) notes to all 21 slides
Notes are presenter-only (addNotes), not on the slide body; one per slide in
slide order, grounded in the real numbers.

Co-Authored-By: Claude Opus 4.8 <noreply@anthropic.com>
</commit_message>
<xml_diff>
--- a/reports/presentation.pptx
+++ b/reports/presentation.pptx
@@ -1351,7 +1351,7 @@
           <a:p>
             <a:r>
               <a:rPr lang="en-US" dirty="0"/>
-              <a:t/>
+              <a:t>פתיחה: הציגו את עצמכם ואת הנושא במשפט — מערכת אחזור מידע בעברית שמגשרת בין שפת היומיום של אזרחים לבין הניסוח הרשמי של זכויות. שאלת-העל: האם חיפוש מבוסס-משמעות מנצח חיפוש מבוסס-מילים, והאם שילוב מנצח את שניהם. מסלול 3 — פרויקט מונחה-נתונים.</a:t>
             </a:r>
             <a:endParaRPr lang="en-US" dirty="0"/>
           </a:p>
@@ -1439,7 +1439,7 @@
           <a:p>
             <a:r>
               <a:rPr lang="en-US" dirty="0"/>
-              <a:t/>
+              <a:t>הדגמה חיה על שאלה אחת. ”פיטרו אותי“: הלקסיקלי מחמיץ לגמרי (אפס מילים משותפות), הסמנטי מדרג ”דמי אבטלה“ ראשון. שימו לב להגינות — ההיברידי כאן רק במקום 4. הוא לא תמיד ראשון לכל שאלה; יתרונו הוא במצטבר. (תשובה מצוינת לשאלת הגנה.)</a:t>
             </a:r>
             <a:endParaRPr lang="en-US" dirty="0"/>
           </a:p>
@@ -1527,7 +1527,7 @@
           <a:p>
             <a:r>
               <a:rPr lang="en-US" dirty="0"/>
-              <a:t/>
+              <a:t>RRF — נוסחה מבוססת-דירוג, ללא צורך בכיול ציונים, ולכן יציבה. המדדים: Recall@k (האם יש תשובה ב-top-k), MRR (דירוג התשובה הנכונה הראשונה), nDCG ו-MAP. המדידה היא ברמת המסמך — פסקה נחשבת עבור הדף שלה.</a:t>
             </a:r>
             <a:endParaRPr lang="en-US" dirty="0"/>
           </a:p>
@@ -1615,7 +1615,7 @@
           <a:p>
             <a:r>
               <a:rPr lang="en-US" dirty="0"/>
-              <a:t/>
+              <a:t>השקופית שעונה על ”איפה החלוקה לטסט/ולידציה“: זו בעיית אחזור ולכן החלוקה ברמת השאילתה. הקורפוס משמש כאינדקס (ללא תוויות); 40 השאלות מחולקות dev=14 / test=26, stratified לפי תחום, seed 42. לא כיווננו על השאלות ⇒ הטסט בלתי-מוטה. על הטסט המוחזק ההיברידי מוביל (MRR 0.690).</a:t>
             </a:r>
             <a:endParaRPr lang="en-US" dirty="0"/>
           </a:p>
@@ -1703,7 +1703,7 @@
           <a:p>
             <a:r>
               <a:rPr lang="en-US" dirty="0"/>
-              <a:t/>
+              <a:t>הטבלה והגרף: Hybrid-RRF מוביל בכל מדדי הדירוג (MRR 0.668, nDCG 0.704, MAP 0.652). שימו לב ש-AlephBERT לבדו (בכתום) הוא דווקא המודל החלש ביותר.</a:t>
             </a:r>
             <a:endParaRPr lang="en-US" dirty="0"/>
           </a:p>
@@ -1791,7 +1791,7 @@
           <a:p>
             <a:r>
               <a:rPr lang="en-US" dirty="0"/>
-              <a:t/>
+              <a:t>שני משפטים: H1 נדחתה — הסמנטי לבדו הכי חלש ואינו מנצח אפילו בשאלות עם פער-ניסוח גבוה. H2 אושרה — ההיברידי מוביל. מדוע? המודלים טועים במקומות שונים, והשילוב משלים. המסר: משלימים, לא עדיפים.</a:t>
             </a:r>
             <a:endParaRPr lang="en-US" dirty="0"/>
           </a:p>
@@ -1879,7 +1879,7 @@
           <a:p>
             <a:r>
               <a:rPr lang="en-US" dirty="0"/>
-              <a:t/>
+              <a:t>עקומת Recall@k וטבלת Recall@1 לפי פער-ניסוח. הנקודה: אפילו בפער גבוה הסמנטי אינו מקדים (0.44 מול 0.48) — מפריך את האינטואיציה. הסיבה: AlephBERT אינו מכוונן-אחזור (נגזר מ-masked-LM).</a:t>
             </a:r>
             <a:endParaRPr lang="en-US" dirty="0"/>
           </a:p>
@@ -1967,7 +1967,7 @@
           <a:p>
             <a:r>
               <a:rPr lang="en-US" dirty="0"/>
-              <a:t/>
+              <a:t>כל שורה היא שאלה; הצבע = דירוג התשובה הנכונה הראשונה. ירוקים ואפורים מתחלפים בין העמודות — המודלים נכשלים בשאלות שונות. אי-ההסכמה הזו היא בדיוק מה שהופך את השילוב למשתלם. החטאות: TF-IDF 6, AlephBERT 9, היברידי 5.</a:t>
             </a:r>
             <a:endParaRPr lang="en-US" dirty="0"/>
           </a:p>
@@ -2055,7 +2055,7 @@
           <a:p>
             <a:r>
               <a:rPr lang="en-US" dirty="0"/>
-              <a:t/>
+              <a:t>ניתוח שגיאות (דרישה: ≥10 דוגמאות; לנו 16): שלוש תבניות — A הסמנטי מנצח (סינונימיה/פער-ניסוח), B הלקסיקלי מנצח (מונח מדויק וחד), C שניהם נכשלים (כיסוי דל/אמביגואיות). הציגו דוגמה אחת מכל תבנית.</a:t>
             </a:r>
             <a:endParaRPr lang="en-US" dirty="0"/>
           </a:p>
@@ -2143,7 +2143,7 @@
           <a:p>
             <a:r>
               <a:rPr lang="en-US" dirty="0"/>
-              <a:t/>
+              <a:t>מרחב ההטמעות של AlephBERT בהיטל דו-ממדי: התחומים יוצרים אשכולות — המודל אכן לוכד משמעות נושאית — אך האשכולות חופפים, ולכן דירוג עדין עדיין זקוק לאות הלקסיקלי. זה ממחיש למה השילוב עוזר.</a:t>
             </a:r>
             <a:endParaRPr lang="en-US" dirty="0"/>
           </a:p>
@@ -2231,7 +2231,7 @@
           <a:p>
             <a:r>
               <a:rPr lang="en-US" dirty="0"/>
-              <a:t/>
+              <a:t>מסקנות: בנינו צינור IR עברי מלא וניתן לשחזור; ההיברידי הוא ההמלצה המעשית; מודל עברי מהמדף אינו ניצחון חינם לאחזור — אלא משלים. המשך: מודל מכוון-אחזור (E5), למטיזציה עברית, וסט הערכה גדול ומדורג יותר.</a:t>
             </a:r>
             <a:endParaRPr lang="en-US" dirty="0"/>
           </a:p>
@@ -2319,7 +2319,7 @@
           <a:p>
             <a:r>
               <a:rPr lang="en-US" dirty="0"/>
-              <a:t/>
+              <a:t>הסבירו את הפער: אזרח כותב ”פיטרו אותי, מה מגיע לי?“ אך הדף נקרא ”זכאות לדמי אבטלה“ — לרוב אפס מילים משותפות. כאן בדיוק חיפוש מילולי נכשל. זו בעיה חברתית אמיתית: זכויות לא ממומשות כי אנשים לא מוצאים את המידע.</a:t>
             </a:r>
             <a:endParaRPr lang="en-US" dirty="0"/>
           </a:p>
@@ -2407,7 +2407,7 @@
           <a:p>
             <a:r>
               <a:rPr lang="en-US" dirty="0"/>
-              <a:t/>
+              <a:t>אתיקה: נתונים ציבוריים ומורשים (CC-BY-SA), ללא מידע אישי; המערכת אינה ייעוץ משפטי — אב-טיפוס מחקרי שחייב להפנות לרשות; הטיות אפשריות וכיסוי מוגבל לשישה תחומים; סט הערכה קטן (מצביע ולא מובהק).</a:t>
             </a:r>
             <a:endParaRPr lang="en-US" dirty="0"/>
           </a:p>
@@ -2495,7 +2495,7 @@
           <a:p>
             <a:r>
               <a:rPr lang="en-US" dirty="0"/>
-              <a:t/>
+              <a:t>סיכום ותודה. גילוי נאות: נעשה שימוש בעוזר AI ככלי לכתיבת קוד בלבד; תכנון המחקר, הנתונים, סט ההערכה והמסקנות הם שלי, וכל הקוד נבדק והובן. הזמינו שאלות להגנה.</a:t>
             </a:r>
             <a:endParaRPr lang="en-US" dirty="0"/>
           </a:p>
@@ -2583,7 +2583,7 @@
           <a:p>
             <a:r>
               <a:rPr lang="en-US" dirty="0"/>
-              <a:t/>
+              <a:t>שתי השערות: H1 — הסמנטי (AlephBERT) ינצח את הלקסיקלי, במיוחד בשאלות מנוסחות-רחוק. H2 — שילוב ינצח את שניהם. ספוילר: H2 התאשרה, H1 נדחתה — והניגוד הזה הוא הממצא המעניין של הפרויקט.</a:t>
             </a:r>
             <a:endParaRPr lang="en-US" dirty="0"/>
           </a:p>
@@ -2671,7 +2671,7 @@
           <a:p>
             <a:r>
               <a:rPr lang="en-US" dirty="0"/>
-              <a:t/>
+              <a:t>סקירת ה-Pipeline המלא (דרישת מסלול 3): איסוף ← עיבוד מקדים ← אינדוקס ← שילוב ← הערכה. הכול רץ בפקודה אחת וניתן לשחזור מלא. הקריאה היא מימין לשמאל — איסוף ראשון.</a:t>
             </a:r>
             <a:endParaRPr lang="en-US" dirty="0"/>
           </a:p>
@@ -2759,7 +2759,7 @@
           <a:p>
             <a:r>
               <a:rPr lang="en-US" dirty="0"/>
-              <a:t/>
+              <a:t>קורפוס שנאסף עצמאית (ללא Kaggle): 296 מסמכים, 1,602 פסקאות. מקור עיקרי — כל-זכות דרך MediaWiki API (טקסט נקי, רישיון CC-BY-SA); משלים — ביטוח לאומי. סט הערכה: 40 שאלות יומיומיות שכתבנו ידנית עם מסמכי אמת. הזכירו שכיבדנו robots.txt.</a:t>
             </a:r>
             <a:endParaRPr lang="en-US" dirty="0"/>
           </a:p>
@@ -2847,7 +2847,7 @@
           <a:p>
             <a:r>
               <a:rPr lang="en-US" dirty="0"/>
-              <a:t/>
+              <a:t>כאן ה-NLP הבסיסי שנלמד בקורס: נרמול (הסרת ניקוד, פיסוק), טוקניזציה, והסרת 94 מילות עצירה. דוגמה: פסקה של 33 טוקנים יורדת ל-26 טוקני תוכן. זה הזרם שמזין את המודלים הלקסיקליים.</a:t>
             </a:r>
             <a:endParaRPr lang="en-US" dirty="0"/>
           </a:p>
@@ -2935,7 +2935,7 @@
           <a:p>
             <a:r>
               <a:rPr lang="en-US" dirty="0"/>
-              <a:t/>
+              <a:t>הקורפוס הופך למטריצת מסמך-מונח בגודל 1,602×20,981, דלילה ב-99.58%. מימין — דוגמה לפסקה כוקטור דליל: רק מספר מונחים מקבלים משקל. הדירוג מחושב כדמיון קוסינוס בין וקטור השאילתה לפסקאות. זהו ה-baseline הלקסיקלי.</a:t>
             </a:r>
             <a:endParaRPr lang="en-US" dirty="0"/>
           </a:p>
@@ -3023,7 +3023,7 @@
           <a:p>
             <a:r>
               <a:rPr lang="en-US" dirty="0"/>
-              <a:t/>
+              <a:t>אתגר העברית: מיליות (ב/ל/מ/ה/ו/ש/כ) נדבקות למילים ומנפחות את אוצר המילים. ניסוי הסרת תחילית מצמצם 13,415→8,963 סוגי מילים (−33%). זה מסביר למה הלקסיקלי מתקשה; למטיזציה מלאה היא עבודה עתידית.</a:t>
             </a:r>
             <a:endParaRPr lang="en-US" dirty="0"/>
           </a:p>
@@ -3111,7 +3111,7 @@
           <a:p>
             <a:r>
               <a:rPr lang="en-US" dirty="0"/>
-              <a:t/>
+              <a:t>חמישה מאחזרים בממשק אחד: TF-IDF ו-BM25 (לקסיקליים), AlephBERT (סמנטי), ושני היברידים — RRF ומשוקלל. ההנחיות דרשו לפחות שתי גישות; לנו יש חמש.</a:t>
             </a:r>
             <a:endParaRPr lang="en-US" dirty="0"/>
           </a:p>

</xml_diff>